<commit_message>
feat(ingesta): antivirus en la subida (EICAR + ClamAV opcional + tope tamaño)
Escaneo del archivo antes de procesarlo (blueprint: upload → antivirus):
- app/security/antivirus.py: firma estándar EICAR (determinista, sin infra) +
  ClamAV opcional si hay daemon (host/puerto o socket) + tope de tamaño.
- documents.upload rechaza (422) y audita los archivos infectados/grandes.
- Config: ANTIVIRUS_ENABLED, CLAMAV_HOST/PORT/SOCKET, MAX_UPLOAD_MB.
- Pruebas: limpio/EICAR/oversize + bloqueo y archivo limpio por la API. 198 verde.
- Docs v2 + CHANGELOG + ESTADO: antivirus marcado como hecho.

Co-Authored-By: Claude Opus 4.8 <noreply@anthropic.com>
Claude-Session: https://claude.ai/code/session_01HTAvTHuepv1vkFtVGxRvVu
</commit_message>
<xml_diff>
--- a/docs/generados/MaestroAI-Tecnico-v2.pptx
+++ b/docs/generados/MaestroAI-Tecnico-v2.pptx
@@ -3257,7 +3257,7 @@
                   <a:srgbClr val="334155"/>
                 </a:solidFill>
               </a:rPr>
-              <a:t>Ingesta avanzada — antivirus + OCR: </a:t>
+              <a:t>OCR de escaneados (completar ingesta avanzada): </a:t>
             </a:r>
             <a:r>
               <a:rPr sz="1200">
@@ -3265,7 +3265,7 @@
                   <a:srgbClr val="64748B"/>
                 </a:solidFill>
               </a:rPr>
-              <a:t>Escanear con antivirus el archivo subido y aplicar OCR a PDFs escaneados (sin capa de texto).</a:t>
+              <a:t>Aplicar OCR a PDFs escaneados sin capa de texto (el antivirus en la ingesta ya quedó hecho).</a:t>
             </a:r>
           </a:p>
           <a:p>

</xml_diff>

<commit_message>
feat(seguridad): MFA (TOTP) + OCR de escaneados en la imagen
MFA (blueprint «RBAC + MFA»):
- app/mfa.py (pyotp): secreto TOTP cifrado, enrolamiento, verificación y códigos
  de respaldo de un solo uso.
- /auth/mfa/setup|verify|disable; el login exige código si MFA está activo (solo
  si hay secreto enrolado → sin lockout). Seed: demo admin sin MFA.
- UI: sección en Mi cuenta (activar/verificar/respaldo/desactivar) + reto en login.
- Pruebas: enrolar→verificar→login exige código→respaldo de un solo uso→desactivar.

OCR de escaneados:
- Dockerfile instala tesseract-ocr + poppler; requirements + pytesseract/pdf2image.
  Los PDFs sin capa de texto pasan por OCR en la ingesta (degrada si no hay binario).

200 pruebas en verde; tsc del portal limpio. Docs v2 + CHANGELOG + ESTADO.

Co-Authored-By: Claude Opus 4.8 <noreply@anthropic.com>
Claude-Session: https://claude.ai/code/session_01HTAvTHuepv1vkFtVGxRvVu
</commit_message>
<xml_diff>
--- a/docs/generados/MaestroAI-Tecnico-v2.pptx
+++ b/docs/generados/MaestroAI-Tecnico-v2.pptx
@@ -3245,52 +3245,6 @@
             <a:spAutoFit/>
           </a:bodyPr>
           <a:lstStyle/>
-          <a:p>
-            <a:pPr>
-              <a:spcAft>
-                <a:spcPts val="500"/>
-              </a:spcAft>
-            </a:pPr>
-            <a:r>
-              <a:rPr b="1" sz="1400">
-                <a:solidFill>
-                  <a:srgbClr val="334155"/>
-                </a:solidFill>
-              </a:rPr>
-              <a:t>OCR de escaneados (completar ingesta avanzada): </a:t>
-            </a:r>
-            <a:r>
-              <a:rPr sz="1200">
-                <a:solidFill>
-                  <a:srgbClr val="64748B"/>
-                </a:solidFill>
-              </a:rPr>
-              <a:t>Aplicar OCR a PDFs escaneados sin capa de texto (el antivirus en la ingesta ya quedó hecho).</a:t>
-            </a:r>
-          </a:p>
-          <a:p>
-            <a:pPr>
-              <a:spcAft>
-                <a:spcPts val="500"/>
-              </a:spcAft>
-            </a:pPr>
-            <a:r>
-              <a:rPr b="1" sz="1400">
-                <a:solidFill>
-                  <a:srgbClr val="334155"/>
-                </a:solidFill>
-              </a:rPr>
-              <a:t>MFA (multi-factor) — TOTP: </a:t>
-            </a:r>
-            <a:r>
-              <a:rPr sz="1200">
-                <a:solidFill>
-                  <a:srgbClr val="64748B"/>
-                </a:solidFill>
-              </a:rPr>
-              <a:t>Segundo factor en el login (app autenticadora) con enrolamiento, verificación y códigos de respaldo.</a:t>
-            </a:r>
-          </a:p>
           <a:p>
             <a:pPr>
               <a:spcAft>

</xml_diff>

<commit_message>
feat(finetune): andamiaje LoRA (datasets/anonimización/gate/jobs) + lab local
Fase 5 del blueprint (parte de software, independiente de GPU):
- Modelos FineTuneDataset/Example/Job; router /finetune (ADMIN/DEVOPS).
- Ejemplos anonimizados (PII redactada) al guardar; gate de calidad + red-team
  (mínimo de ejemplos, sin PII residual, sin inyección); export JSONL (chat).
- from-memory: construye dataset desde trabajos en Memoria.
- jobs: despacho a trainer externo (FINETUNE_TRAINER_URL: servidor GPU / App NaN /
  webhook n8n) o 'simulado' (laboratorio); callback para reportar adapter/serve_base_url.
- Config FINETUNE_*; guía docs/FINETUNING-SETUP.md (lab con GPU local + Ollama + n8n).
- Pruebas: anonimización, gate, from-memory, job simulado + callback. 204 en verde.

Co-Authored-By: Claude Opus 4.8 <noreply@anthropic.com>
Claude-Session: https://claude.ai/code/session_01HTAvTHuepv1vkFtVGxRvVu
</commit_message>
<xml_diff>
--- a/docs/generados/MaestroAI-Tecnico-v2.pptx
+++ b/docs/generados/MaestroAI-Tecnico-v2.pptx
@@ -3257,7 +3257,7 @@
                   <a:srgbClr val="334155"/>
                 </a:solidFill>
               </a:rPr>
-              <a:t>Fine-tuning ligero (LoRA): </a:t>
+              <a:t>Fine-tuning LoRA — entrenamiento real en GPU: </a:t>
             </a:r>
             <a:r>
               <a:rPr sz="1200">
@@ -3265,7 +3265,7 @@
                   <a:srgbClr val="64748B"/>
                 </a:solidFill>
               </a:rPr>
-              <a:t>Pipeline de dataset → anonimización → versionado → entrenamiento LoRA → evals → red team → despliegue.</a:t>
+              <a:t>Conectar el andamiaje (ya hecho: datasets/anonimización/gate/jobs) a un trainer con GPU que entrene el adapter y lo sirva.</a:t>
             </a:r>
           </a:p>
           <a:p>

</xml_diff>